<commit_message>
Draw architecture diagram on Slide 3 in PPTX
</commit_message>
<xml_diff>
--- a/LinkSphere_Presentation.pptx
+++ b/LinkSphere_Presentation.pptx
@@ -3590,14 +3590,481 @@
       </p:sp>
       <p:sp>
         <p:nvSpPr>
-          <p:cNvPr id="4" name="TextBox 3"/>
+          <p:cNvPr id="4" name="Rounded Rectangle 3"/>
+          <p:cNvSpPr/>
+          <p:nvPr/>
+        </p:nvSpPr>
+        <p:spPr>
+          <a:xfrm>
+            <a:off x="731520" y="2011680"/>
+            <a:ext cx="2011680" cy="914400"/>
+          </a:xfrm>
+          <a:prstGeom prst="roundRect">
+            <a:avLst/>
+          </a:prstGeom>
+          <a:solidFill>
+            <a:srgbClr val="1E293B"/>
+          </a:solidFill>
+          <a:ln w="19050">
+            <a:solidFill>
+              <a:srgbClr val="F1F5F9"/>
+            </a:solidFill>
+          </a:ln>
+        </p:spPr>
+        <p:style>
+          <a:lnRef idx="1">
+            <a:schemeClr val="accent1"/>
+          </a:lnRef>
+          <a:fillRef idx="3">
+            <a:schemeClr val="accent1"/>
+          </a:fillRef>
+          <a:effectRef idx="2">
+            <a:schemeClr val="accent1"/>
+          </a:effectRef>
+          <a:fontRef idx="minor">
+            <a:schemeClr val="lt1"/>
+          </a:fontRef>
+        </p:style>
+        <p:txBody>
+          <a:bodyPr rtlCol="0" anchor="ctr" wrap="square"/>
+          <a:lstStyle/>
+          <a:p>
+            <a:pPr algn="ctr">
+              <a:defRPr sz="1300" b="1">
+                <a:solidFill>
+                  <a:srgbClr val="F1F5F9"/>
+                </a:solidFill>
+                <a:latin typeface="Arial"/>
+              </a:defRPr>
+            </a:pPr>
+            <a:r>
+              <a:t>🔗 Vite + React UI</a:t>
+            </a:r>
+            <a:br/>
+            <a:r>
+              <a:t>(Frontend Client)</a:t>
+            </a:r>
+          </a:p>
+        </p:txBody>
+      </p:sp>
+      <p:sp>
+        <p:nvSpPr>
+          <p:cNvPr id="5" name="Rounded Rectangle 4"/>
+          <p:cNvSpPr/>
+          <p:nvPr/>
+        </p:nvSpPr>
+        <p:spPr>
+          <a:xfrm>
+            <a:off x="3474720" y="2011680"/>
+            <a:ext cx="2011680" cy="914400"/>
+          </a:xfrm>
+          <a:prstGeom prst="roundRect">
+            <a:avLst/>
+          </a:prstGeom>
+          <a:solidFill>
+            <a:srgbClr val="1E293B"/>
+          </a:solidFill>
+          <a:ln w="19050">
+            <a:solidFill>
+              <a:srgbClr val="38BDF8"/>
+            </a:solidFill>
+          </a:ln>
+        </p:spPr>
+        <p:style>
+          <a:lnRef idx="1">
+            <a:schemeClr val="accent1"/>
+          </a:lnRef>
+          <a:fillRef idx="3">
+            <a:schemeClr val="accent1"/>
+          </a:fillRef>
+          <a:effectRef idx="2">
+            <a:schemeClr val="accent1"/>
+          </a:effectRef>
+          <a:fontRef idx="minor">
+            <a:schemeClr val="lt1"/>
+          </a:fontRef>
+        </p:style>
+        <p:txBody>
+          <a:bodyPr rtlCol="0" anchor="ctr" wrap="square"/>
+          <a:lstStyle/>
+          <a:p>
+            <a:pPr algn="ctr">
+              <a:defRPr sz="1300" b="1">
+                <a:solidFill>
+                  <a:srgbClr val="F1F5F9"/>
+                </a:solidFill>
+                <a:latin typeface="Arial"/>
+              </a:defRPr>
+            </a:pPr>
+            <a:r>
+              <a:t>🛡️ Vercel Proxy</a:t>
+            </a:r>
+            <a:br/>
+            <a:r>
+              <a:t>(Rewrite Gateway)</a:t>
+            </a:r>
+          </a:p>
+        </p:txBody>
+      </p:sp>
+      <p:sp>
+        <p:nvSpPr>
+          <p:cNvPr id="6" name="Rounded Rectangle 5"/>
+          <p:cNvSpPr/>
+          <p:nvPr/>
+        </p:nvSpPr>
+        <p:spPr>
+          <a:xfrm>
+            <a:off x="3474720" y="3657600"/>
+            <a:ext cx="2011680" cy="914400"/>
+          </a:xfrm>
+          <a:prstGeom prst="roundRect">
+            <a:avLst/>
+          </a:prstGeom>
+          <a:solidFill>
+            <a:srgbClr val="1E293B"/>
+          </a:solidFill>
+          <a:ln w="19050">
+            <a:solidFill>
+              <a:srgbClr val="38BDF8"/>
+            </a:solidFill>
+          </a:ln>
+        </p:spPr>
+        <p:style>
+          <a:lnRef idx="1">
+            <a:schemeClr val="accent1"/>
+          </a:lnRef>
+          <a:fillRef idx="3">
+            <a:schemeClr val="accent1"/>
+          </a:fillRef>
+          <a:effectRef idx="2">
+            <a:schemeClr val="accent1"/>
+          </a:effectRef>
+          <a:fontRef idx="minor">
+            <a:schemeClr val="lt1"/>
+          </a:fontRef>
+        </p:style>
+        <p:txBody>
+          <a:bodyPr rtlCol="0" anchor="ctr" wrap="square"/>
+          <a:lstStyle/>
+          <a:p>
+            <a:pPr algn="ctr">
+              <a:defRPr sz="1300" b="1">
+                <a:solidFill>
+                  <a:srgbClr val="F1F5F9"/>
+                </a:solidFill>
+                <a:latin typeface="Arial"/>
+              </a:defRPr>
+            </a:pPr>
+            <a:r>
+              <a:t>⚙️ Node + Express</a:t>
+            </a:r>
+            <a:br/>
+            <a:r>
+              <a:t>(Backend REST API)</a:t>
+            </a:r>
+          </a:p>
+        </p:txBody>
+      </p:sp>
+      <p:sp>
+        <p:nvSpPr>
+          <p:cNvPr id="7" name="Rounded Rectangle 6"/>
+          <p:cNvSpPr/>
+          <p:nvPr/>
+        </p:nvSpPr>
+        <p:spPr>
+          <a:xfrm>
+            <a:off x="1371600" y="5303520"/>
+            <a:ext cx="2011680" cy="914400"/>
+          </a:xfrm>
+          <a:prstGeom prst="roundRect">
+            <a:avLst/>
+          </a:prstGeom>
+          <a:solidFill>
+            <a:srgbClr val="1E293B"/>
+          </a:solidFill>
+          <a:ln w="19050">
+            <a:solidFill>
+              <a:srgbClr val="10B981"/>
+            </a:solidFill>
+          </a:ln>
+        </p:spPr>
+        <p:style>
+          <a:lnRef idx="1">
+            <a:schemeClr val="accent1"/>
+          </a:lnRef>
+          <a:fillRef idx="3">
+            <a:schemeClr val="accent1"/>
+          </a:fillRef>
+          <a:effectRef idx="2">
+            <a:schemeClr val="accent1"/>
+          </a:effectRef>
+          <a:fontRef idx="minor">
+            <a:schemeClr val="lt1"/>
+          </a:fontRef>
+        </p:style>
+        <p:txBody>
+          <a:bodyPr rtlCol="0" anchor="ctr" wrap="square"/>
+          <a:lstStyle/>
+          <a:p>
+            <a:pPr algn="ctr">
+              <a:defRPr sz="1300" b="1">
+                <a:solidFill>
+                  <a:srgbClr val="F1F5F9"/>
+                </a:solidFill>
+                <a:latin typeface="Arial"/>
+              </a:defRPr>
+            </a:pPr>
+            <a:r>
+              <a:t>🍃 MongoDB Atlas</a:t>
+            </a:r>
+            <a:br/>
+            <a:r>
+              <a:t>(Document Store)</a:t>
+            </a:r>
+          </a:p>
+        </p:txBody>
+      </p:sp>
+      <p:sp>
+        <p:nvSpPr>
+          <p:cNvPr id="8" name="Rounded Rectangle 7"/>
+          <p:cNvSpPr/>
+          <p:nvPr/>
+        </p:nvSpPr>
+        <p:spPr>
+          <a:xfrm>
+            <a:off x="4114800" y="5303520"/>
+            <a:ext cx="2011680" cy="914400"/>
+          </a:xfrm>
+          <a:prstGeom prst="roundRect">
+            <a:avLst/>
+          </a:prstGeom>
+          <a:solidFill>
+            <a:srgbClr val="1E293B"/>
+          </a:solidFill>
+          <a:ln w="19050">
+            <a:solidFill>
+              <a:srgbClr val="EF4444"/>
+            </a:solidFill>
+          </a:ln>
+        </p:spPr>
+        <p:style>
+          <a:lnRef idx="1">
+            <a:schemeClr val="accent1"/>
+          </a:lnRef>
+          <a:fillRef idx="3">
+            <a:schemeClr val="accent1"/>
+          </a:fillRef>
+          <a:effectRef idx="2">
+            <a:schemeClr val="accent1"/>
+          </a:effectRef>
+          <a:fontRef idx="minor">
+            <a:schemeClr val="lt1"/>
+          </a:fontRef>
+        </p:style>
+        <p:txBody>
+          <a:bodyPr rtlCol="0" anchor="ctr" wrap="square"/>
+          <a:lstStyle/>
+          <a:p>
+            <a:pPr algn="ctr">
+              <a:defRPr sz="1300" b="1">
+                <a:solidFill>
+                  <a:srgbClr val="F1F5F9"/>
+                </a:solidFill>
+                <a:latin typeface="Arial"/>
+              </a:defRPr>
+            </a:pPr>
+            <a:r>
+              <a:t>🔴 Upstash Redis</a:t>
+            </a:r>
+            <a:br/>
+            <a:r>
+              <a:t>(Serverless Cache)</a:t>
+            </a:r>
+          </a:p>
+        </p:txBody>
+      </p:sp>
+      <p:sp>
+        <p:nvSpPr>
+          <p:cNvPr id="9" name="Right Arrow 8"/>
+          <p:cNvSpPr/>
+          <p:nvPr/>
+        </p:nvSpPr>
+        <p:spPr>
+          <a:xfrm>
+            <a:off x="2880360" y="2331720"/>
+            <a:ext cx="457200" cy="274320"/>
+          </a:xfrm>
+          <a:prstGeom prst="rightArrow">
+            <a:avLst/>
+          </a:prstGeom>
+          <a:solidFill>
+            <a:srgbClr val="94A3B8"/>
+          </a:solidFill>
+          <a:ln>
+            <a:noFill/>
+          </a:ln>
+        </p:spPr>
+        <p:style>
+          <a:lnRef idx="1">
+            <a:schemeClr val="accent1"/>
+          </a:lnRef>
+          <a:fillRef idx="3">
+            <a:schemeClr val="accent1"/>
+          </a:fillRef>
+          <a:effectRef idx="2">
+            <a:schemeClr val="accent1"/>
+          </a:effectRef>
+          <a:fontRef idx="minor">
+            <a:schemeClr val="lt1"/>
+          </a:fontRef>
+        </p:style>
+        <p:txBody>
+          <a:bodyPr rtlCol="0" anchor="ctr"/>
+          <a:lstStyle/>
+          <a:p>
+            <a:pPr algn="ctr"/>
+          </a:p>
+        </p:txBody>
+      </p:sp>
+      <p:sp>
+        <p:nvSpPr>
+          <p:cNvPr id="10" name="Down Arrow 9"/>
+          <p:cNvSpPr/>
+          <p:nvPr/>
+        </p:nvSpPr>
+        <p:spPr>
+          <a:xfrm>
+            <a:off x="4343400" y="3063240"/>
+            <a:ext cx="274320" cy="457200"/>
+          </a:xfrm>
+          <a:prstGeom prst="downArrow">
+            <a:avLst/>
+          </a:prstGeom>
+          <a:solidFill>
+            <a:srgbClr val="94A3B8"/>
+          </a:solidFill>
+          <a:ln>
+            <a:noFill/>
+          </a:ln>
+        </p:spPr>
+        <p:style>
+          <a:lnRef idx="1">
+            <a:schemeClr val="accent1"/>
+          </a:lnRef>
+          <a:fillRef idx="3">
+            <a:schemeClr val="accent1"/>
+          </a:fillRef>
+          <a:effectRef idx="2">
+            <a:schemeClr val="accent1"/>
+          </a:effectRef>
+          <a:fontRef idx="minor">
+            <a:schemeClr val="lt1"/>
+          </a:fontRef>
+        </p:style>
+        <p:txBody>
+          <a:bodyPr rtlCol="0" anchor="ctr"/>
+          <a:lstStyle/>
+          <a:p>
+            <a:pPr algn="ctr"/>
+          </a:p>
+        </p:txBody>
+      </p:sp>
+      <p:sp>
+        <p:nvSpPr>
+          <p:cNvPr id="11" name="Down Arrow 10"/>
+          <p:cNvSpPr/>
+          <p:nvPr/>
+        </p:nvSpPr>
+        <p:spPr>
+          <a:xfrm>
+            <a:off x="2240280" y="4709160"/>
+            <a:ext cx="274320" cy="457200"/>
+          </a:xfrm>
+          <a:prstGeom prst="downArrow">
+            <a:avLst/>
+          </a:prstGeom>
+          <a:solidFill>
+            <a:srgbClr val="94A3B8"/>
+          </a:solidFill>
+          <a:ln>
+            <a:noFill/>
+          </a:ln>
+        </p:spPr>
+        <p:style>
+          <a:lnRef idx="1">
+            <a:schemeClr val="accent1"/>
+          </a:lnRef>
+          <a:fillRef idx="3">
+            <a:schemeClr val="accent1"/>
+          </a:fillRef>
+          <a:effectRef idx="2">
+            <a:schemeClr val="accent1"/>
+          </a:effectRef>
+          <a:fontRef idx="minor">
+            <a:schemeClr val="lt1"/>
+          </a:fontRef>
+        </p:style>
+        <p:txBody>
+          <a:bodyPr rtlCol="0" anchor="ctr"/>
+          <a:lstStyle/>
+          <a:p>
+            <a:pPr algn="ctr"/>
+          </a:p>
+        </p:txBody>
+      </p:sp>
+      <p:sp>
+        <p:nvSpPr>
+          <p:cNvPr id="12" name="Down Arrow 11"/>
+          <p:cNvSpPr/>
+          <p:nvPr/>
+        </p:nvSpPr>
+        <p:spPr>
+          <a:xfrm>
+            <a:off x="4983480" y="4709160"/>
+            <a:ext cx="274320" cy="457200"/>
+          </a:xfrm>
+          <a:prstGeom prst="downArrow">
+            <a:avLst/>
+          </a:prstGeom>
+          <a:solidFill>
+            <a:srgbClr val="94A3B8"/>
+          </a:solidFill>
+          <a:ln>
+            <a:noFill/>
+          </a:ln>
+        </p:spPr>
+        <p:style>
+          <a:lnRef idx="1">
+            <a:schemeClr val="accent1"/>
+          </a:lnRef>
+          <a:fillRef idx="3">
+            <a:schemeClr val="accent1"/>
+          </a:fillRef>
+          <a:effectRef idx="2">
+            <a:schemeClr val="accent1"/>
+          </a:effectRef>
+          <a:fontRef idx="minor">
+            <a:schemeClr val="lt1"/>
+          </a:fontRef>
+        </p:style>
+        <p:txBody>
+          <a:bodyPr rtlCol="0" anchor="ctr"/>
+          <a:lstStyle/>
+          <a:p>
+            <a:pPr algn="ctr"/>
+          </a:p>
+        </p:txBody>
+      </p:sp>
+      <p:sp>
+        <p:nvSpPr>
+          <p:cNvPr id="13" name="TextBox 12"/>
           <p:cNvSpPr txBox="1"/>
           <p:nvPr/>
         </p:nvSpPr>
         <p:spPr>
           <a:xfrm>
-            <a:off x="731520" y="1645920"/>
-            <a:ext cx="2560320" cy="4389120"/>
+            <a:off x="6583680" y="1645920"/>
+            <a:ext cx="4846320" cy="4572000"/>
           </a:xfrm>
           <a:prstGeom prst="rect">
             <a:avLst/>
@@ -3612,9 +4079,9 @@
           <a:p>
             <a:pPr>
               <a:spcAft>
-                <a:spcPts val="800"/>
+                <a:spcPts val="1400"/>
               </a:spcAft>
-              <a:defRPr sz="1800" b="1">
+              <a:defRPr sz="2000" b="1">
                 <a:solidFill>
                   <a:srgbClr val="38BDF8"/>
                 </a:solidFill>
@@ -3622,7 +4089,7 @@
               </a:defRPr>
             </a:pPr>
             <a:r>
-              <a:t>1. FRONTEND TIER</a:t>
+              <a:t>⚙️ DECOUPLED DATA FLOW</a:t>
             </a:r>
           </a:p>
           <a:p>
@@ -3630,7 +4097,7 @@
               <a:spcAft>
                 <a:spcPts val="1200"/>
               </a:spcAft>
-              <a:defRPr sz="1400" i="1" b="1">
+              <a:defRPr sz="1500">
                 <a:solidFill>
                   <a:srgbClr val="F1F5F9"/>
                 </a:solidFill>
@@ -3638,62 +4105,7 @@
               </a:defRPr>
             </a:pPr>
             <a:r>
-              <a:t>React + Vite + Tailwind</a:t>
-            </a:r>
-          </a:p>
-          <a:p>
-            <a:pPr>
-              <a:spcAft>
-                <a:spcPts val="800"/>
-              </a:spcAft>
-              <a:defRPr sz="1300">
-                <a:solidFill>
-                  <a:srgbClr val="94A3B8"/>
-                </a:solidFill>
-                <a:latin typeface="Arial"/>
-              </a:defRPr>
-            </a:pPr>
-            <a:r>
-              <a:t>Handles interactive dashboard rendering, Recharts visualization, dynamic QR downloads, and authentication forms.</a:t>
-            </a:r>
-          </a:p>
-        </p:txBody>
-      </p:sp>
-      <p:sp>
-        <p:nvSpPr>
-          <p:cNvPr id="5" name="TextBox 4"/>
-          <p:cNvSpPr txBox="1"/>
-          <p:nvPr/>
-        </p:nvSpPr>
-        <p:spPr>
-          <a:xfrm>
-            <a:off x="3429000" y="1645920"/>
-            <a:ext cx="2560320" cy="4389120"/>
-          </a:xfrm>
-          <a:prstGeom prst="rect">
-            <a:avLst/>
-          </a:prstGeom>
-          <a:noFill/>
-        </p:spPr>
-        <p:txBody>
-          <a:bodyPr wrap="square">
-            <a:spAutoFit/>
-          </a:bodyPr>
-          <a:lstStyle/>
-          <a:p>
-            <a:pPr>
-              <a:spcAft>
-                <a:spcPts val="800"/>
-              </a:spcAft>
-              <a:defRPr sz="1800" b="1">
-                <a:solidFill>
-                  <a:srgbClr val="38BDF8"/>
-                </a:solidFill>
-                <a:latin typeface="Arial"/>
-              </a:defRPr>
-            </a:pPr>
-            <a:r>
-              <a:t>2. GATEWAY PROXY</a:t>
+              <a:t>•  Vercel Edge Proxy handles SSL and rewrites client requests starting with /api/v1 to the Render URL, completely resolving CORS restrictions.</a:t>
             </a:r>
           </a:p>
           <a:p>
@@ -3701,7 +4113,7 @@
               <a:spcAft>
                 <a:spcPts val="1200"/>
               </a:spcAft>
-              <a:defRPr sz="1400" i="1" b="1">
+              <a:defRPr sz="1500">
                 <a:solidFill>
                   <a:srgbClr val="F1F5F9"/>
                 </a:solidFill>
@@ -3709,62 +4121,7 @@
               </a:defRPr>
             </a:pPr>
             <a:r>
-              <a:t>Vercel Engine / Nginx</a:t>
-            </a:r>
-          </a:p>
-          <a:p>
-            <a:pPr>
-              <a:spcAft>
-                <a:spcPts val="800"/>
-              </a:spcAft>
-              <a:defRPr sz="1300">
-                <a:solidFill>
-                  <a:srgbClr val="94A3B8"/>
-                </a:solidFill>
-                <a:latin typeface="Arial"/>
-              </a:defRPr>
-            </a:pPr>
-            <a:r>
-              <a:t>Manages route rewriting, proxying client API calls to backend without CORS errors, and securing SSL/TLS termination.</a:t>
-            </a:r>
-          </a:p>
-        </p:txBody>
-      </p:sp>
-      <p:sp>
-        <p:nvSpPr>
-          <p:cNvPr id="6" name="TextBox 5"/>
-          <p:cNvSpPr txBox="1"/>
-          <p:nvPr/>
-        </p:nvSpPr>
-        <p:spPr>
-          <a:xfrm>
-            <a:off x="6126480" y="1645920"/>
-            <a:ext cx="2560320" cy="4389120"/>
-          </a:xfrm>
-          <a:prstGeom prst="rect">
-            <a:avLst/>
-          </a:prstGeom>
-          <a:noFill/>
-        </p:spPr>
-        <p:txBody>
-          <a:bodyPr wrap="square">
-            <a:spAutoFit/>
-          </a:bodyPr>
-          <a:lstStyle/>
-          <a:p>
-            <a:pPr>
-              <a:spcAft>
-                <a:spcPts val="800"/>
-              </a:spcAft>
-              <a:defRPr sz="1800" b="1">
-                <a:solidFill>
-                  <a:srgbClr val="38BDF8"/>
-                </a:solidFill>
-                <a:latin typeface="Arial"/>
-              </a:defRPr>
-            </a:pPr>
-            <a:r>
-              <a:t>3. BACKEND API TIER</a:t>
+              <a:t>•  Node API queries MongoDB Atlas only for cold requests; popular shortened links are served directly from Upstash Redis to keep latency sub-2ms.</a:t>
             </a:r>
           </a:p>
           <a:p>
@@ -3772,7 +4129,7 @@
               <a:spcAft>
                 <a:spcPts val="1200"/>
               </a:spcAft>
-              <a:defRPr sz="1400" i="1" b="1">
+              <a:defRPr sz="1500">
                 <a:solidFill>
                   <a:srgbClr val="F1F5F9"/>
                 </a:solidFill>
@@ -3780,94 +4137,7 @@
               </a:defRPr>
             </a:pPr>
             <a:r>
-              <a:t>Node.js + Express.js</a:t>
-            </a:r>
-          </a:p>
-          <a:p>
-            <a:pPr>
-              <a:spcAft>
-                <a:spcPts val="800"/>
-              </a:spcAft>
-              <a:defRPr sz="1300">
-                <a:solidFill>
-                  <a:srgbClr val="94A3B8"/>
-                </a:solidFill>
-                <a:latin typeface="Arial"/>
-              </a:defRPr>
-            </a:pPr>
-            <a:r>
-              <a:t>MVC architecture processing link creation, device/browser metadata parsing, JWT verification, and background jobs.</a:t>
-            </a:r>
-          </a:p>
-        </p:txBody>
-      </p:sp>
-      <p:sp>
-        <p:nvSpPr>
-          <p:cNvPr id="7" name="TextBox 6"/>
-          <p:cNvSpPr txBox="1"/>
-          <p:nvPr/>
-        </p:nvSpPr>
-        <p:spPr>
-          <a:xfrm>
-            <a:off x="8823960" y="1645920"/>
-            <a:ext cx="2560320" cy="4389120"/>
-          </a:xfrm>
-          <a:prstGeom prst="rect">
-            <a:avLst/>
-          </a:prstGeom>
-          <a:noFill/>
-        </p:spPr>
-        <p:txBody>
-          <a:bodyPr wrap="square">
-            <a:spAutoFit/>
-          </a:bodyPr>
-          <a:lstStyle/>
-          <a:p>
-            <a:pPr>
-              <a:spcAft>
-                <a:spcPts val="800"/>
-              </a:spcAft>
-              <a:defRPr sz="1800" b="1">
-                <a:solidFill>
-                  <a:srgbClr val="38BDF8"/>
-                </a:solidFill>
-                <a:latin typeface="Arial"/>
-              </a:defRPr>
-            </a:pPr>
-            <a:r>
-              <a:t>4. DATABASE &amp; CACHE</a:t>
-            </a:r>
-          </a:p>
-          <a:p>
-            <a:pPr>
-              <a:spcAft>
-                <a:spcPts val="1200"/>
-              </a:spcAft>
-              <a:defRPr sz="1400" i="1" b="1">
-                <a:solidFill>
-                  <a:srgbClr val="F1F5F9"/>
-                </a:solidFill>
-                <a:latin typeface="Arial"/>
-              </a:defRPr>
-            </a:pPr>
-            <a:r>
-              <a:t>MongoDB + Upstash Redis</a:t>
-            </a:r>
-          </a:p>
-          <a:p>
-            <a:pPr>
-              <a:spcAft>
-                <a:spcPts val="800"/>
-              </a:spcAft>
-              <a:defRPr sz="1300">
-                <a:solidFill>
-                  <a:srgbClr val="94A3B8"/>
-                </a:solidFill>
-                <a:latin typeface="Arial"/>
-              </a:defRPr>
-            </a:pPr>
-            <a:r>
-              <a:t>MongoDB stores persistent data (Users, Links, Clicks). Redis acts as memory cache for hot redirection and rate-limiter storage.</a:t>
+              <a:t>•  Visitor metadata (Browser, OS, referral source) is parsed out of the request headers and saved asynchronously to the MongoDB Click analytics collection.</a:t>
             </a:r>
           </a:p>
         </p:txBody>

</xml_diff>